<commit_message>
docs: streamline readme and presentation with enterprise architecture focus
</commit_message>
<xml_diff>
--- a/presentation/Online_Project_Management_Tool_Presentation.pptx
+++ b/presentation/Online_Project_Management_Tool_Presentation.pptx
@@ -3176,7 +3176,7 @@
               </a:defRPr>
             </a:pPr>
             <a:r>
-              <a:t>ACADEMIC PROJECT PRESENTATION</a:t>
+              <a:t>ENTERPRISE ARCHITECTURE PRESENTATION</a:t>
             </a:r>
           </a:p>
           <a:p>
@@ -4348,7 +4348,7 @@
               </a:defRPr>
             </a:pPr>
             <a:r>
-              <a:t>Conclusion &amp; Academic Rubric Compliance</a:t>
+              <a:t>Conclusion &amp; Architectural Summary</a:t>
             </a:r>
           </a:p>
         </p:txBody>
@@ -4431,97 +4431,97 @@
               </a:defRPr>
             </a:pPr>
             <a:r>
-              <a:t>Academic Rubric Compliance (Full Marks Target)</a:t>
-            </a:r>
-          </a:p>
-          <a:p>
-            <a:pPr>
-              <a:spcAft>
-                <a:spcPts val="600"/>
-              </a:spcAft>
-              <a:defRPr sz="1200">
-                <a:solidFill>
-                  <a:srgbClr val="1E293B"/>
-                </a:solidFill>
-              </a:defRPr>
-            </a:pPr>
-            <a:r>
-              <a:t>• OOP Concepts (10 Marks): BaseEntity, interfaces, polymorphism, custom exception hierarchy, and clean encapsulation.</a:t>
-            </a:r>
-          </a:p>
-          <a:p>
-            <a:pPr>
-              <a:spcAft>
-                <a:spcPts val="600"/>
-              </a:spcAft>
-              <a:defRPr sz="1200">
-                <a:solidFill>
-                  <a:srgbClr val="1E293B"/>
-                </a:solidFill>
-              </a:defRPr>
-            </a:pPr>
-            <a:r>
-              <a:t>• Collections &amp; Generics (6 Marks): GenericDao&lt;T, ID&gt;, ConcurrentHashMap, LinkedHashMap, and type-safe query results.</a:t>
-            </a:r>
-          </a:p>
-          <a:p>
-            <a:pPr>
-              <a:spcAft>
-                <a:spcPts val="600"/>
-              </a:spcAft>
-              <a:defRPr sz="1200">
-                <a:solidFill>
-                  <a:srgbClr val="1E293B"/>
-                </a:solidFill>
-              </a:defRPr>
-            </a:pPr>
-            <a:r>
-              <a:t>• Multithreading &amp; Synchronization (4 Marks): AsyncWorkerPool, ThreadSafeConnectionPool, ThreadLocal security context, EventBus.</a:t>
-            </a:r>
-          </a:p>
-          <a:p>
-            <a:pPr>
-              <a:spcAft>
-                <a:spcPts val="600"/>
-              </a:spcAft>
-              <a:defRPr sz="1200">
-                <a:solidFill>
-                  <a:srgbClr val="1E293B"/>
-                </a:solidFill>
-              </a:defRPr>
-            </a:pPr>
-            <a:r>
-              <a:t>• Database Operations &amp; DAO Pattern (7 Marks): Complete DAO layer with 8 specialized repositories and transaction isolation.</a:t>
-            </a:r>
-          </a:p>
-          <a:p>
-            <a:pPr>
-              <a:spcAft>
-                <a:spcPts val="600"/>
-              </a:spcAft>
-              <a:defRPr sz="1200">
-                <a:solidFill>
-                  <a:srgbClr val="1E293B"/>
-                </a:solidFill>
-              </a:defRPr>
-            </a:pPr>
-            <a:r>
-              <a:t>• JDBC Connectivity (3 Marks): Standard java.sql.Driver, Connection, PreparedStatement, and ResultSet implementation.</a:t>
-            </a:r>
-          </a:p>
-          <a:p>
-            <a:pPr>
-              <a:spcAft>
-                <a:spcPts val="600"/>
-              </a:spcAft>
-              <a:defRPr sz="1200">
-                <a:solidFill>
-                  <a:srgbClr val="1E293B"/>
-                </a:solidFill>
-              </a:defRPr>
-            </a:pPr>
-            <a:r>
-              <a:t>• Servlets &amp; Web Integration (7 Marks): Lightweight HTTP server, DispatcherServlet, FilterChain, and REST controllers.</a:t>
+              <a:t>Core Technical Foundations</a:t>
+            </a:r>
+          </a:p>
+          <a:p>
+            <a:pPr>
+              <a:spcAft>
+                <a:spcPts val="600"/>
+              </a:spcAft>
+              <a:defRPr sz="1200">
+                <a:solidFill>
+                  <a:srgbClr val="1E293B"/>
+                </a:solidFill>
+              </a:defRPr>
+            </a:pPr>
+            <a:r>
+              <a:t>• Object-Oriented Design: BaseEntity, domain interfaces, polymorphism, custom exception hierarchy, and clean encapsulation.</a:t>
+            </a:r>
+          </a:p>
+          <a:p>
+            <a:pPr>
+              <a:spcAft>
+                <a:spcPts val="600"/>
+              </a:spcAft>
+              <a:defRPr sz="1200">
+                <a:solidFill>
+                  <a:srgbClr val="1E293B"/>
+                </a:solidFill>
+              </a:defRPr>
+            </a:pPr>
+            <a:r>
+              <a:t>• Collections &amp; Generics: GenericDao&lt;T, ID&gt;, ConcurrentHashMap, LinkedHashMap, and type-safe query results.</a:t>
+            </a:r>
+          </a:p>
+          <a:p>
+            <a:pPr>
+              <a:spcAft>
+                <a:spcPts val="600"/>
+              </a:spcAft>
+              <a:defRPr sz="1200">
+                <a:solidFill>
+                  <a:srgbClr val="1E293B"/>
+                </a:solidFill>
+              </a:defRPr>
+            </a:pPr>
+            <a:r>
+              <a:t>• Multithreading &amp; Synchronization: AsyncWorkerPool, ThreadSafeConnectionPool, ThreadLocal security context, and EventBus.</a:t>
+            </a:r>
+          </a:p>
+          <a:p>
+            <a:pPr>
+              <a:spcAft>
+                <a:spcPts val="600"/>
+              </a:spcAft>
+              <a:defRPr sz="1200">
+                <a:solidFill>
+                  <a:srgbClr val="1E293B"/>
+                </a:solidFill>
+              </a:defRPr>
+            </a:pPr>
+            <a:r>
+              <a:t>• Database Operations &amp; DAO Pattern: Complete DAO layer with 8 specialized repositories and transaction isolation.</a:t>
+            </a:r>
+          </a:p>
+          <a:p>
+            <a:pPr>
+              <a:spcAft>
+                <a:spcPts val="600"/>
+              </a:spcAft>
+              <a:defRPr sz="1200">
+                <a:solidFill>
+                  <a:srgbClr val="1E293B"/>
+                </a:solidFill>
+              </a:defRPr>
+            </a:pPr>
+            <a:r>
+              <a:t>• Standard JDBC Connectivity: Pure java.sql.Driver, Connection, PreparedStatement, and ResultSet implementation.</a:t>
+            </a:r>
+          </a:p>
+          <a:p>
+            <a:pPr>
+              <a:spcAft>
+                <a:spcPts val="600"/>
+              </a:spcAft>
+              <a:defRPr sz="1200">
+                <a:solidFill>
+                  <a:srgbClr val="1E293B"/>
+                </a:solidFill>
+              </a:defRPr>
+            </a:pPr>
+            <a:r>
+              <a:t>• Servlets &amp; Web Integration: Lightweight HTTP server, DispatcherServlet, FilterChain, and RESTful controllers.</a:t>
             </a:r>
           </a:p>
         </p:txBody>
@@ -4619,22 +4619,22 @@
               </a:defRPr>
             </a:pPr>
             <a:r>
-              <a:t>• Git Repository: 30 structured, systematic human commits mapping development progression from init to delivery.</a:t>
-            </a:r>
-          </a:p>
-          <a:p>
-            <a:pPr>
-              <a:spcAft>
-                <a:spcPts val="600"/>
-              </a:spcAft>
-              <a:defRPr sz="1200">
-                <a:solidFill>
-                  <a:srgbClr val="1E293B"/>
-                </a:solidFill>
-              </a:defRPr>
-            </a:pPr>
-            <a:r>
-              <a:t>• Presentation File: Comprehensive 13-slide executive presentation file (Online_Project_Management_Tool_Presentation.pptx).</a:t>
+              <a:t>• Version Control: Systematic, cleanly structured commits tracking modular engineering progression.</a:t>
+            </a:r>
+          </a:p>
+          <a:p>
+            <a:pPr>
+              <a:spcAft>
+                <a:spcPts val="600"/>
+              </a:spcAft>
+              <a:defRPr sz="1200">
+                <a:solidFill>
+                  <a:srgbClr val="1E293B"/>
+                </a:solidFill>
+              </a:defRPr>
+            </a:pPr>
+            <a:r>
+              <a:t>• Presentation Deck: 13-slide executive presentation deck (Online_Project_Management_Tool_Presentation.pptx).</a:t>
             </a:r>
           </a:p>
           <a:p>
@@ -4664,7 +4664,7 @@
               </a:defRPr>
             </a:pPr>
             <a:r>
-              <a:t>• Production Documentation: Comprehensive README.md with architecture diagrams, rubric mapping, and REST API catalog.</a:t>
+              <a:t>• Production Documentation: Comprehensive README.md with architecture diagrams, setup guide, and REST API catalog.</a:t>
             </a:r>
           </a:p>
           <a:p>
@@ -6855,7 +6855,7 @@
               </a:defRPr>
             </a:pPr>
             <a:r>
-              <a:t>Core Java &amp; OOP Implementation (Rubric: 10 Marks)</a:t>
+              <a:t>Core Java &amp; Object-Oriented Architecture</a:t>
             </a:r>
           </a:p>
         </p:txBody>
@@ -7209,7 +7209,7 @@
               </a:defRPr>
             </a:pPr>
             <a:r>
-              <a:t>Collections Framework &amp; Generics (Rubric: 6 Marks)</a:t>
+              <a:t>Collections Framework &amp; Type-Safe Generics</a:t>
             </a:r>
           </a:p>
         </p:txBody>
@@ -7563,7 +7563,7 @@
               </a:defRPr>
             </a:pPr>
             <a:r>
-              <a:t>Multithreading &amp; Synchronization (Rubric: 4 Marks)</a:t>
+              <a:t>Multithreading, Concurrency &amp; Synchronization</a:t>
             </a:r>
           </a:p>
         </p:txBody>

</xml_diff>